<commit_message>
feat/docs(T65): MCP cap-governance tools (16), deck + verification pkg id v1.0.4, TASKS T65/T66
</commit_message>
<xml_diff>
--- a/docs/deck/NetChain-Pitch.pptx
+++ b/docs/deck/NetChain-Pitch.pptx
@@ -2484,7 +2484,7 @@
                 <a:ea typeface="Segoe UI" pitchFamily="34" charset="-122"/>
                 <a:cs typeface="Segoe UI" pitchFamily="34" charset="-120"/>
               </a:rPr>
-              <a:t>v1.0.0 → v1.0.3 as live SCUs, no downtime, including today's bilateral confirmation.</a:t>
+              <a:t>v1.0.0 → v1.0.4 as live SCUs, no downtime: settlement fix, bilateral confirmation, maker-checker cap governance.</a:t>
             </a:r>
             <a:endParaRPr lang="en-US" sz="1350" dirty="0"/>
           </a:p>
@@ -2628,7 +2628,7 @@
                 <a:ea typeface="Consolas" pitchFamily="34" charset="-122"/>
                 <a:cs typeface="Consolas" pitchFamily="34" charset="-120"/>
               </a:rPr>
-              <a:t>pkg v1.0.3  219a350c…61eed0</a:t>
+              <a:t>pkg v1.0.4  8ae58d7c…768cbb</a:t>
             </a:r>
             <a:endParaRPr lang="en-US" sz="1200" dirty="0"/>
           </a:p>
@@ -7154,7 +7154,7 @@
                 <a:ea typeface="Segoe UI" pitchFamily="34" charset="-122"/>
                 <a:cs typeface="Segoe UI" pitchFamily="34" charset="-120"/>
               </a:rPr>
-              <a:t>12 MCP tools, including accept_obligation, so agents honor bilateral consent.</a:t>
+              <a:t>16 MCP tools. An agent can't self-approve a debt (bilateral consent) or raise its own cap (maker-checker).</a:t>
             </a:r>
             <a:endParaRPr lang="en-US" sz="1600" dirty="0"/>
           </a:p>

</xml_diff>